<commit_message>
Deck and results page rebuilt with Thursday's close: equity 99,434.93, minus 565.07
Also fixed the negative money format on the P&L tile: the sign now sits
outside the currency symbol, so it reads -$565 and not $-565.
</commit_message>
<xml_diff>
--- a/presentation/slides.pptx
+++ b/presentation/slides.pptx
@@ -2120,7 +2120,7 @@
                 <a:ea typeface="Cambria" pitchFamily="34" charset="-122"/>
                 <a:cs typeface="Cambria" pitchFamily="34" charset="-120"/>
               </a:rPr>
-              <a:t>1,052</a:t>
+              <a:t>1,390</a:t>
             </a:r>
             <a:endParaRPr lang="en-US" sz="3400" dirty="0"/>
           </a:p>
@@ -2225,7 +2225,7 @@
                 <a:ea typeface="Cambria" pitchFamily="34" charset="-122"/>
                 <a:cs typeface="Cambria" pitchFamily="34" charset="-120"/>
               </a:rPr>
-              <a:t>147 of 151</a:t>
+              <a:t>193 of 197</a:t>
             </a:r>
             <a:endParaRPr lang="en-US" sz="3400" dirty="0"/>
           </a:p>
@@ -2591,7 +2591,7 @@
                 <a:ea typeface="Courier New" pitchFamily="34" charset="-122"/>
                 <a:cs typeface="Courier New" pitchFamily="34" charset="-120"/>
               </a:rPr>
-              <a:t>root 345ad42360dc4999...</a:t>
+              <a:t>root e4ce452c697f8c90...</a:t>
             </a:r>
             <a:endParaRPr lang="en-US" sz="900" dirty="0"/>
           </a:p>
@@ -2787,7 +2787,7 @@
                 <a:ea typeface="Courier New" pitchFamily="34" charset="-122"/>
                 <a:cs typeface="Courier New" pitchFamily="34" charset="-120"/>
               </a:rPr>
-              <a:t>345ad42360dc4999...
+              <a:t>e4ce452c697f8c90...
 </a:t>
             </a:r>
             <a:endParaRPr lang="en-US" sz="1300" dirty="0"/>
@@ -2825,7 +2825,7 @@
                 <a:ea typeface="Courier New" pitchFamily="34" charset="-122"/>
                 <a:cs typeface="Courier New" pitchFamily="34" charset="-120"/>
               </a:rPr>
-              <a:t>345ad42360dc4999...   MATCHES
+              <a:t>e4ce452c697f8c90...   MATCHES
 </a:t>
             </a:r>
             <a:endParaRPr lang="en-US" sz="1300" dirty="0"/>
@@ -3161,7 +3161,7 @@
                 <a:ea typeface="Courier New" pitchFamily="34" charset="-122"/>
                 <a:cs typeface="Courier New" pitchFamily="34" charset="-120"/>
               </a:rPr>
-              <a:t>root 345ad42360dc4999...</a:t>
+              <a:t>root e4ce452c697f8c90...</a:t>
             </a:r>
             <a:endParaRPr lang="en-US" sz="900" dirty="0"/>
           </a:p>
@@ -3310,7 +3310,7 @@
                 <a:ea typeface="Calibri" pitchFamily="34" charset="-122"/>
                 <a:cs typeface="Calibri" pitchFamily="34" charset="-120"/>
               </a:rPr>
-              <a:t>Read from the sealed log when this deck was built: 2026-09-03 09:25 UTC. Rebuild the deck, the numbers move.</a:t>
+              <a:t>Read from the sealed log when this deck was built: 2026-09-04 07:44 UTC. Rebuild the deck, the numbers move.</a:t>
             </a:r>
             <a:endParaRPr lang="en-US" sz="1500" dirty="0"/>
           </a:p>
@@ -3376,7 +3376,7 @@
                 <a:ea typeface="Cambria" pitchFamily="34" charset="-122"/>
                 <a:cs typeface="Cambria" pitchFamily="34" charset="-120"/>
               </a:rPr>
-              <a:t>$100,142</a:t>
+              <a:t>$99,435</a:t>
             </a:r>
             <a:endParaRPr lang="en-US" sz="3400" dirty="0"/>
           </a:p>
@@ -3475,13 +3475,13 @@
             <a:r>
               <a:rPr lang="en-US" sz="3400" b="1" dirty="0">
                 <a:solidFill>
-                  <a:srgbClr val="E8B54A"/>
+                  <a:srgbClr val="E08A93"/>
                 </a:solidFill>
                 <a:latin typeface="Cambria" pitchFamily="34" charset="0"/>
                 <a:ea typeface="Cambria" pitchFamily="34" charset="-122"/>
                 <a:cs typeface="Cambria" pitchFamily="34" charset="-120"/>
               </a:rPr>
-              <a:t>+$142</a:t>
+              <a:t>-$565</a:t>
             </a:r>
             <a:endParaRPr lang="en-US" sz="3400" dirty="0"/>
           </a:p>
@@ -4132,7 +4132,7 @@
                 <a:ea typeface="Courier New" pitchFamily="34" charset="-122"/>
                 <a:cs typeface="Courier New" pitchFamily="34" charset="-120"/>
               </a:rPr>
-              <a:t>root 345ad42360dc4999...</a:t>
+              <a:t>root e4ce452c697f8c90...</a:t>
             </a:r>
             <a:endParaRPr lang="en-US" sz="900" dirty="0"/>
           </a:p>
@@ -4782,7 +4782,7 @@
                 <a:ea typeface="Courier New" pitchFamily="34" charset="-122"/>
                 <a:cs typeface="Courier New" pitchFamily="34" charset="-120"/>
               </a:rPr>
-              <a:t>root 345ad42360dc4999...</a:t>
+              <a:t>root e4ce452c697f8c90...</a:t>
             </a:r>
             <a:endParaRPr lang="en-US" sz="900" dirty="0"/>
           </a:p>
@@ -5244,7 +5244,7 @@
                 <a:ea typeface="Courier New" pitchFamily="34" charset="-122"/>
                 <a:cs typeface="Courier New" pitchFamily="34" charset="-120"/>
               </a:rPr>
-              <a:t>root 345ad42360dc4999...</a:t>
+              <a:t>root e4ce452c697f8c90...</a:t>
             </a:r>
             <a:endParaRPr lang="en-US" sz="900" dirty="0"/>
           </a:p>
@@ -5459,7 +5459,7 @@
                 <a:ea typeface="Cambria" pitchFamily="34" charset="-122"/>
                 <a:cs typeface="Cambria" pitchFamily="34" charset="-120"/>
               </a:rPr>
-              <a:t>97%</a:t>
+              <a:t>98%</a:t>
             </a:r>
             <a:endParaRPr lang="en-US" sz="5400" dirty="0"/>
           </a:p>
@@ -5739,7 +5739,7 @@
                 <a:ea typeface="Calibri" pitchFamily="34" charset="-122"/>
                 <a:cs typeface="Calibri" pitchFamily="34" charset="-120"/>
               </a:rPr>
-              <a:t>entry ladder unfilled (all gates passed)</a:t>
+              <a:t>event_proximity</a:t>
             </a:r>
             <a:endParaRPr lang="en-US" sz="1200" dirty="0"/>
           </a:p>
@@ -5754,6 +5754,106 @@
         <p:spPr>
           <a:xfrm>
             <a:off x="4937760" y="5047488"/>
+            <a:ext cx="1658799" cy="237744"/>
+          </a:xfrm>
+          <a:prstGeom prst="roundRect">
+            <a:avLst>
+              <a:gd name="adj" fmla="val 23077"/>
+            </a:avLst>
+          </a:prstGeom>
+          <a:solidFill>
+            <a:srgbClr val="1E3550"/>
+          </a:solidFill>
+          <a:ln/>
+        </p:spPr>
+      </p:sp>
+      <p:sp>
+        <p:nvSpPr>
+          <p:cNvPr id="14" name="Text 12"/>
+          <p:cNvSpPr txBox="1"/>
+          <p:nvPr/>
+        </p:nvSpPr>
+        <p:spPr>
+          <a:xfrm>
+            <a:off x="6706287" y="4983480"/>
+            <a:ext cx="822960" cy="365760"/>
+          </a:xfrm>
+          <a:prstGeom prst="rect">
+            <a:avLst/>
+          </a:prstGeom>
+          <a:noFill/>
+          <a:ln/>
+        </p:spPr>
+        <p:txBody>
+          <a:bodyPr wrap="square" lIns="0" tIns="0" rIns="0" bIns="0" rtlCol="0" anchor="ctr"/>
+          <a:lstStyle/>
+          <a:p>
+            <a:pPr indent="0" marL="0">
+              <a:buNone/>
+            </a:pPr>
+            <a:r>
+              <a:rPr lang="en-US" sz="1200" dirty="0">
+                <a:solidFill>
+                  <a:srgbClr val="FFFFFF"/>
+                </a:solidFill>
+                <a:latin typeface="Courier New" pitchFamily="34" charset="0"/>
+                <a:ea typeface="Courier New" pitchFamily="34" charset="-122"/>
+                <a:cs typeface="Courier New" pitchFamily="34" charset="-120"/>
+              </a:rPr>
+              <a:t>46</a:t>
+            </a:r>
+            <a:endParaRPr lang="en-US" sz="1200" dirty="0"/>
+          </a:p>
+        </p:txBody>
+      </p:sp>
+      <p:sp>
+        <p:nvSpPr>
+          <p:cNvPr id="15" name="Text 13"/>
+          <p:cNvSpPr txBox="1"/>
+          <p:nvPr/>
+        </p:nvSpPr>
+        <p:spPr>
+          <a:xfrm>
+            <a:off x="640080" y="5486400"/>
+            <a:ext cx="4206240" cy="365760"/>
+          </a:xfrm>
+          <a:prstGeom prst="rect">
+            <a:avLst/>
+          </a:prstGeom>
+          <a:noFill/>
+          <a:ln/>
+        </p:spPr>
+        <p:txBody>
+          <a:bodyPr wrap="square" lIns="0" tIns="0" rIns="0" bIns="0" rtlCol="0" anchor="ctr"/>
+          <a:lstStyle/>
+          <a:p>
+            <a:pPr indent="0" marL="0">
+              <a:buNone/>
+            </a:pPr>
+            <a:r>
+              <a:rPr lang="en-US" sz="1200" dirty="0">
+                <a:solidFill>
+                  <a:srgbClr val="C9DAF0"/>
+                </a:solidFill>
+                <a:latin typeface="Calibri" pitchFamily="34" charset="0"/>
+                <a:ea typeface="Calibri" pitchFamily="34" charset="-122"/>
+                <a:cs typeface="Calibri" pitchFamily="34" charset="-120"/>
+              </a:rPr>
+              <a:t>entry ladder unfilled (all gates passed)</a:t>
+            </a:r>
+            <a:endParaRPr lang="en-US" sz="1200" dirty="0"/>
+          </a:p>
+        </p:txBody>
+      </p:sp>
+      <p:sp>
+        <p:nvSpPr>
+          <p:cNvPr id="16" name="Shape 14"/>
+          <p:cNvSpPr/>
+          <p:nvPr/>
+        </p:nvSpPr>
+        <p:spPr>
+          <a:xfrm>
+            <a:off x="4937760" y="5550408"/>
             <a:ext cx="228600" cy="237744"/>
           </a:xfrm>
           <a:prstGeom prst="roundRect">
@@ -5769,13 +5869,13 @@
       </p:sp>
       <p:sp>
         <p:nvSpPr>
-          <p:cNvPr id="14" name="Text 12"/>
-          <p:cNvSpPr txBox="1"/>
-          <p:nvPr/>
-        </p:nvSpPr>
-        <p:spPr>
-          <a:xfrm>
-            <a:off x="5276088" y="4983480"/>
+          <p:cNvPr id="17" name="Text 15"/>
+          <p:cNvSpPr txBox="1"/>
+          <p:nvPr/>
+        </p:nvSpPr>
+        <p:spPr>
+          <a:xfrm>
+            <a:off x="5276088" y="5486400"/>
             <a:ext cx="822960" cy="365760"/>
           </a:xfrm>
           <a:prstGeom prst="rect">
@@ -5808,138 +5908,38 @@
       </p:sp>
       <p:sp>
         <p:nvSpPr>
-          <p:cNvPr id="15" name="Text 13"/>
-          <p:cNvSpPr txBox="1"/>
-          <p:nvPr/>
-        </p:nvSpPr>
-        <p:spPr>
-          <a:xfrm>
-            <a:off x="640080" y="5486400"/>
-            <a:ext cx="4206240" cy="365760"/>
-          </a:xfrm>
-          <a:prstGeom prst="rect">
-            <a:avLst/>
-          </a:prstGeom>
-          <a:noFill/>
-          <a:ln/>
-        </p:spPr>
-        <p:txBody>
-          <a:bodyPr wrap="square" lIns="0" tIns="0" rIns="0" bIns="0" rtlCol="0" anchor="ctr"/>
-          <a:lstStyle/>
-          <a:p>
-            <a:pPr indent="0" marL="0">
-              <a:buNone/>
-            </a:pPr>
-            <a:r>
-              <a:rPr lang="en-US" sz="1200" dirty="0">
-                <a:solidFill>
-                  <a:srgbClr val="C9DAF0"/>
-                </a:solidFill>
-                <a:latin typeface="Calibri" pitchFamily="34" charset="0"/>
-                <a:ea typeface="Calibri" pitchFamily="34" charset="-122"/>
-                <a:cs typeface="Calibri" pitchFamily="34" charset="-120"/>
-              </a:rPr>
-              <a:t>vrp_threshold</a:t>
-            </a:r>
-            <a:endParaRPr lang="en-US" sz="1200" dirty="0"/>
-          </a:p>
-        </p:txBody>
-      </p:sp>
-      <p:sp>
-        <p:nvSpPr>
-          <p:cNvPr id="16" name="Shape 14"/>
-          <p:cNvSpPr/>
-          <p:nvPr/>
-        </p:nvSpPr>
-        <p:spPr>
-          <a:xfrm>
-            <a:off x="4937760" y="5550408"/>
-            <a:ext cx="228600" cy="237744"/>
-          </a:xfrm>
-          <a:prstGeom prst="roundRect">
-            <a:avLst>
-              <a:gd name="adj" fmla="val 24000"/>
-            </a:avLst>
-          </a:prstGeom>
-          <a:solidFill>
-            <a:srgbClr val="1E3550"/>
-          </a:solidFill>
-          <a:ln/>
-        </p:spPr>
-      </p:sp>
-      <p:sp>
-        <p:nvSpPr>
-          <p:cNvPr id="17" name="Text 15"/>
-          <p:cNvSpPr txBox="1"/>
-          <p:nvPr/>
-        </p:nvSpPr>
-        <p:spPr>
-          <a:xfrm>
-            <a:off x="5276088" y="5486400"/>
-            <a:ext cx="822960" cy="365760"/>
-          </a:xfrm>
-          <a:prstGeom prst="rect">
-            <a:avLst/>
-          </a:prstGeom>
-          <a:noFill/>
-          <a:ln/>
-        </p:spPr>
-        <p:txBody>
-          <a:bodyPr wrap="square" lIns="0" tIns="0" rIns="0" bIns="0" rtlCol="0" anchor="ctr"/>
-          <a:lstStyle/>
-          <a:p>
-            <a:pPr indent="0" marL="0">
-              <a:buNone/>
-            </a:pPr>
-            <a:r>
-              <a:rPr lang="en-US" sz="1200" dirty="0">
-                <a:solidFill>
-                  <a:srgbClr val="FFFFFF"/>
+          <p:cNvPr id="18" name="Text 16"/>
+          <p:cNvSpPr txBox="1"/>
+          <p:nvPr/>
+        </p:nvSpPr>
+        <p:spPr>
+          <a:xfrm>
+            <a:off x="640080" y="6382512"/>
+            <a:ext cx="4572000" cy="256032"/>
+          </a:xfrm>
+          <a:prstGeom prst="rect">
+            <a:avLst/>
+          </a:prstGeom>
+          <a:noFill/>
+          <a:ln/>
+        </p:spPr>
+        <p:txBody>
+          <a:bodyPr wrap="square" lIns="0" tIns="0" rIns="0" bIns="0" rtlCol="0" anchor="ctr"/>
+          <a:lstStyle/>
+          <a:p>
+            <a:pPr algn="l" indent="0" marL="0">
+              <a:buNone/>
+            </a:pPr>
+            <a:r>
+              <a:rPr lang="en-US" sz="900" dirty="0">
+                <a:solidFill>
+                  <a:srgbClr val="7C93AE"/>
                 </a:solidFill>
                 <a:latin typeface="Courier New" pitchFamily="34" charset="0"/>
                 <a:ea typeface="Courier New" pitchFamily="34" charset="-122"/>
                 <a:cs typeface="Courier New" pitchFamily="34" charset="-120"/>
               </a:rPr>
-              <a:t>1</a:t>
-            </a:r>
-            <a:endParaRPr lang="en-US" sz="1200" dirty="0"/>
-          </a:p>
-        </p:txBody>
-      </p:sp>
-      <p:sp>
-        <p:nvSpPr>
-          <p:cNvPr id="18" name="Text 16"/>
-          <p:cNvSpPr txBox="1"/>
-          <p:nvPr/>
-        </p:nvSpPr>
-        <p:spPr>
-          <a:xfrm>
-            <a:off x="640080" y="6382512"/>
-            <a:ext cx="4572000" cy="256032"/>
-          </a:xfrm>
-          <a:prstGeom prst="rect">
-            <a:avLst/>
-          </a:prstGeom>
-          <a:noFill/>
-          <a:ln/>
-        </p:spPr>
-        <p:txBody>
-          <a:bodyPr wrap="square" lIns="0" tIns="0" rIns="0" bIns="0" rtlCol="0" anchor="ctr"/>
-          <a:lstStyle/>
-          <a:p>
-            <a:pPr algn="l" indent="0" marL="0">
-              <a:buNone/>
-            </a:pPr>
-            <a:r>
-              <a:rPr lang="en-US" sz="900" dirty="0">
-                <a:solidFill>
-                  <a:srgbClr val="7C93AE"/>
-                </a:solidFill>
-                <a:latin typeface="Courier New" pitchFamily="34" charset="0"/>
-                <a:ea typeface="Courier New" pitchFamily="34" charset="-122"/>
-                <a:cs typeface="Courier New" pitchFamily="34" charset="-120"/>
-              </a:rPr>
-              <a:t>root 345ad42360dc4999...</a:t>
+              <a:t>root e4ce452c697f8c90...</a:t>
             </a:r>
             <a:endParaRPr lang="en-US" sz="900" dirty="0"/>
           </a:p>
@@ -6658,7 +6658,7 @@
                 <a:ea typeface="Courier New" pitchFamily="34" charset="-122"/>
                 <a:cs typeface="Courier New" pitchFamily="34" charset="-120"/>
               </a:rPr>
-              <a:t>root 345ad42360dc4999...</a:t>
+              <a:t>root e4ce452c697f8c90...</a:t>
             </a:r>
             <a:endParaRPr lang="en-US" sz="900" dirty="0"/>
           </a:p>
@@ -7278,7 +7278,7 @@
                 <a:ea typeface="Courier New" pitchFamily="34" charset="-122"/>
                 <a:cs typeface="Courier New" pitchFamily="34" charset="-120"/>
               </a:rPr>
-              <a:t>root 345ad42360dc4999...</a:t>
+              <a:t>root e4ce452c697f8c90...</a:t>
             </a:r>
             <a:endParaRPr lang="en-US" sz="900" dirty="0"/>
           </a:p>
@@ -8981,7 +8981,7 @@
                 <a:ea typeface="Courier New" pitchFamily="34" charset="-122"/>
                 <a:cs typeface="Courier New" pitchFamily="34" charset="-120"/>
               </a:rPr>
-              <a:t>root 345ad42360dc4999...</a:t>
+              <a:t>root e4ce452c697f8c90...</a:t>
             </a:r>
             <a:endParaRPr lang="en-US" sz="900" dirty="0"/>
           </a:p>
@@ -9313,7 +9313,7 @@
                 <a:ea typeface="Calibri" pitchFamily="34" charset="-122"/>
                 <a:cs typeface="Calibri" pitchFamily="34" charset="-120"/>
               </a:rPr>
-              <a:t>would-enter cycles of 48</a:t>
+              <a:t>would-enter cycles of 52</a:t>
             </a:r>
             <a:endParaRPr lang="en-US" sz="1100" dirty="0"/>
           </a:p>
@@ -9496,7 +9496,7 @@
                 <a:ea typeface="Calibri" pitchFamily="34" charset="-122"/>
                 <a:cs typeface="Calibri" pitchFamily="34" charset="-120"/>
               </a:rPr>
-              <a:t>would-enter cycles of 48</a:t>
+              <a:t>would-enter cycles of 52</a:t>
             </a:r>
             <a:endParaRPr lang="en-US" sz="1100" dirty="0"/>
           </a:p>
@@ -9718,7 +9718,7 @@
                 <a:ea typeface="Calibri" pitchFamily="34" charset="-122"/>
                 <a:cs typeface="Calibri" pitchFamily="34" charset="-120"/>
               </a:rPr>
-              <a:t>would-enter cycles of 47</a:t>
+              <a:t>would-enter cycles of 51</a:t>
             </a:r>
             <a:endParaRPr lang="en-US" sz="1100" dirty="0"/>
           </a:p>
@@ -9855,7 +9855,7 @@
                 <a:ea typeface="Courier New" pitchFamily="34" charset="-122"/>
                 <a:cs typeface="Courier New" pitchFamily="34" charset="-120"/>
               </a:rPr>
-              <a:t>root 345ad42360dc4999...</a:t>
+              <a:t>root e4ce452c697f8c90...</a:t>
             </a:r>
             <a:endParaRPr lang="en-US" sz="900" dirty="0"/>
           </a:p>
@@ -10737,7 +10737,7 @@
                 <a:ea typeface="Courier New" pitchFamily="34" charset="-122"/>
                 <a:cs typeface="Courier New" pitchFamily="34" charset="-120"/>
               </a:rPr>
-              <a:t>root 345ad42360dc4999...</a:t>
+              <a:t>root e4ce452c697f8c90...</a:t>
             </a:r>
             <a:endParaRPr lang="en-US" sz="900" dirty="0"/>
           </a:p>
@@ -11492,7 +11492,7 @@
                 <a:ea typeface="Courier New" pitchFamily="34" charset="-122"/>
                 <a:cs typeface="Courier New" pitchFamily="34" charset="-120"/>
               </a:rPr>
-              <a:t>root 345ad42360dc4999...</a:t>
+              <a:t>root e4ce452c697f8c90...</a:t>
             </a:r>
             <a:endParaRPr lang="en-US" sz="900" dirty="0"/>
           </a:p>
@@ -11981,7 +11981,7 @@
                 <a:ea typeface="Cambria" pitchFamily="34" charset="-122"/>
                 <a:cs typeface="Cambria" pitchFamily="34" charset="-120"/>
               </a:rPr>
-              <a:t>181</a:t>
+              <a:t>238</a:t>
             </a:r>
             <a:endParaRPr lang="en-US" sz="3400" dirty="0"/>
           </a:p>
@@ -12269,7 +12269,7 @@
                 <a:ea typeface="Courier New" pitchFamily="34" charset="-122"/>
                 <a:cs typeface="Courier New" pitchFamily="34" charset="-120"/>
               </a:rPr>
-              <a:t>root 345ad42360dc4999...</a:t>
+              <a:t>root e4ce452c697f8c90...</a:t>
             </a:r>
             <a:endParaRPr lang="en-US" sz="900" dirty="0"/>
           </a:p>

</xml_diff>